<commit_message>
Qty Typing & Bill Discount Update
</commit_message>
<xml_diff>
--- a/Assets/Docs/payment Receipt.pptx
+++ b/Assets/Docs/payment Receipt.pptx
@@ -254,7 +254,7 @@
           <a:p>
             <a:fld id="{4FBA4FEC-236F-4868-8F03-87BECBE3AFDA}" type="datetimeFigureOut">
               <a:rPr lang="en-US" smtClean="0"/>
-              <a:t>6/21/2025</a:t>
+              <a:t>7/26/2025</a:t>
             </a:fld>
             <a:endParaRPr lang="en-US"/>
           </a:p>
@@ -424,7 +424,7 @@
           <a:p>
             <a:fld id="{4FBA4FEC-236F-4868-8F03-87BECBE3AFDA}" type="datetimeFigureOut">
               <a:rPr lang="en-US" smtClean="0"/>
-              <a:t>6/21/2025</a:t>
+              <a:t>7/26/2025</a:t>
             </a:fld>
             <a:endParaRPr lang="en-US"/>
           </a:p>
@@ -604,7 +604,7 @@
           <a:p>
             <a:fld id="{4FBA4FEC-236F-4868-8F03-87BECBE3AFDA}" type="datetimeFigureOut">
               <a:rPr lang="en-US" smtClean="0"/>
-              <a:t>6/21/2025</a:t>
+              <a:t>7/26/2025</a:t>
             </a:fld>
             <a:endParaRPr lang="en-US"/>
           </a:p>
@@ -774,7 +774,7 @@
           <a:p>
             <a:fld id="{4FBA4FEC-236F-4868-8F03-87BECBE3AFDA}" type="datetimeFigureOut">
               <a:rPr lang="en-US" smtClean="0"/>
-              <a:t>6/21/2025</a:t>
+              <a:t>7/26/2025</a:t>
             </a:fld>
             <a:endParaRPr lang="en-US"/>
           </a:p>
@@ -1018,7 +1018,7 @@
           <a:p>
             <a:fld id="{4FBA4FEC-236F-4868-8F03-87BECBE3AFDA}" type="datetimeFigureOut">
               <a:rPr lang="en-US" smtClean="0"/>
-              <a:t>6/21/2025</a:t>
+              <a:t>7/26/2025</a:t>
             </a:fld>
             <a:endParaRPr lang="en-US"/>
           </a:p>
@@ -1250,7 +1250,7 @@
           <a:p>
             <a:fld id="{4FBA4FEC-236F-4868-8F03-87BECBE3AFDA}" type="datetimeFigureOut">
               <a:rPr lang="en-US" smtClean="0"/>
-              <a:t>6/21/2025</a:t>
+              <a:t>7/26/2025</a:t>
             </a:fld>
             <a:endParaRPr lang="en-US"/>
           </a:p>
@@ -1617,7 +1617,7 @@
           <a:p>
             <a:fld id="{4FBA4FEC-236F-4868-8F03-87BECBE3AFDA}" type="datetimeFigureOut">
               <a:rPr lang="en-US" smtClean="0"/>
-              <a:t>6/21/2025</a:t>
+              <a:t>7/26/2025</a:t>
             </a:fld>
             <a:endParaRPr lang="en-US"/>
           </a:p>
@@ -1735,7 +1735,7 @@
           <a:p>
             <a:fld id="{4FBA4FEC-236F-4868-8F03-87BECBE3AFDA}" type="datetimeFigureOut">
               <a:rPr lang="en-US" smtClean="0"/>
-              <a:t>6/21/2025</a:t>
+              <a:t>7/26/2025</a:t>
             </a:fld>
             <a:endParaRPr lang="en-US"/>
           </a:p>
@@ -1830,7 +1830,7 @@
           <a:p>
             <a:fld id="{4FBA4FEC-236F-4868-8F03-87BECBE3AFDA}" type="datetimeFigureOut">
               <a:rPr lang="en-US" smtClean="0"/>
-              <a:t>6/21/2025</a:t>
+              <a:t>7/26/2025</a:t>
             </a:fld>
             <a:endParaRPr lang="en-US"/>
           </a:p>
@@ -2107,7 +2107,7 @@
           <a:p>
             <a:fld id="{4FBA4FEC-236F-4868-8F03-87BECBE3AFDA}" type="datetimeFigureOut">
               <a:rPr lang="en-US" smtClean="0"/>
-              <a:t>6/21/2025</a:t>
+              <a:t>7/26/2025</a:t>
             </a:fld>
             <a:endParaRPr lang="en-US"/>
           </a:p>
@@ -2364,7 +2364,7 @@
           <a:p>
             <a:fld id="{4FBA4FEC-236F-4868-8F03-87BECBE3AFDA}" type="datetimeFigureOut">
               <a:rPr lang="en-US" smtClean="0"/>
-              <a:t>6/21/2025</a:t>
+              <a:t>7/26/2025</a:t>
             </a:fld>
             <a:endParaRPr lang="en-US"/>
           </a:p>
@@ -2577,7 +2577,7 @@
           <a:p>
             <a:fld id="{4FBA4FEC-236F-4868-8F03-87BECBE3AFDA}" type="datetimeFigureOut">
               <a:rPr lang="en-US" smtClean="0"/>
-              <a:t>6/21/2025</a:t>
+              <a:t>7/26/2025</a:t>
             </a:fld>
             <a:endParaRPr lang="en-US"/>
           </a:p>

</xml_diff>

<commit_message>
Add special discount support to invoice and reports
Introduces special discount handling in the invoice payment flow, updates UI to allow entry and display of special discounts, and propagates discount values through controllers, models, and report beans. Adjusts calculations and report generation to account for invoice-level discounts, and updates related FXML and Jasper report files accordingly.
</commit_message>
<xml_diff>
--- a/Assets/Docs/payment Receipt.pptx
+++ b/Assets/Docs/payment Receipt.pptx
@@ -254,7 +254,7 @@
           <a:p>
             <a:fld id="{4FBA4FEC-236F-4868-8F03-87BECBE3AFDA}" type="datetimeFigureOut">
               <a:rPr lang="en-US" smtClean="0"/>
-              <a:t>7/26/2025</a:t>
+              <a:t>8/5/2025</a:t>
             </a:fld>
             <a:endParaRPr lang="en-US"/>
           </a:p>
@@ -424,7 +424,7 @@
           <a:p>
             <a:fld id="{4FBA4FEC-236F-4868-8F03-87BECBE3AFDA}" type="datetimeFigureOut">
               <a:rPr lang="en-US" smtClean="0"/>
-              <a:t>7/26/2025</a:t>
+              <a:t>8/5/2025</a:t>
             </a:fld>
             <a:endParaRPr lang="en-US"/>
           </a:p>
@@ -604,7 +604,7 @@
           <a:p>
             <a:fld id="{4FBA4FEC-236F-4868-8F03-87BECBE3AFDA}" type="datetimeFigureOut">
               <a:rPr lang="en-US" smtClean="0"/>
-              <a:t>7/26/2025</a:t>
+              <a:t>8/5/2025</a:t>
             </a:fld>
             <a:endParaRPr lang="en-US"/>
           </a:p>
@@ -774,7 +774,7 @@
           <a:p>
             <a:fld id="{4FBA4FEC-236F-4868-8F03-87BECBE3AFDA}" type="datetimeFigureOut">
               <a:rPr lang="en-US" smtClean="0"/>
-              <a:t>7/26/2025</a:t>
+              <a:t>8/5/2025</a:t>
             </a:fld>
             <a:endParaRPr lang="en-US"/>
           </a:p>
@@ -1018,7 +1018,7 @@
           <a:p>
             <a:fld id="{4FBA4FEC-236F-4868-8F03-87BECBE3AFDA}" type="datetimeFigureOut">
               <a:rPr lang="en-US" smtClean="0"/>
-              <a:t>7/26/2025</a:t>
+              <a:t>8/5/2025</a:t>
             </a:fld>
             <a:endParaRPr lang="en-US"/>
           </a:p>
@@ -1250,7 +1250,7 @@
           <a:p>
             <a:fld id="{4FBA4FEC-236F-4868-8F03-87BECBE3AFDA}" type="datetimeFigureOut">
               <a:rPr lang="en-US" smtClean="0"/>
-              <a:t>7/26/2025</a:t>
+              <a:t>8/5/2025</a:t>
             </a:fld>
             <a:endParaRPr lang="en-US"/>
           </a:p>
@@ -1617,7 +1617,7 @@
           <a:p>
             <a:fld id="{4FBA4FEC-236F-4868-8F03-87BECBE3AFDA}" type="datetimeFigureOut">
               <a:rPr lang="en-US" smtClean="0"/>
-              <a:t>7/26/2025</a:t>
+              <a:t>8/5/2025</a:t>
             </a:fld>
             <a:endParaRPr lang="en-US"/>
           </a:p>
@@ -1735,7 +1735,7 @@
           <a:p>
             <a:fld id="{4FBA4FEC-236F-4868-8F03-87BECBE3AFDA}" type="datetimeFigureOut">
               <a:rPr lang="en-US" smtClean="0"/>
-              <a:t>7/26/2025</a:t>
+              <a:t>8/5/2025</a:t>
             </a:fld>
             <a:endParaRPr lang="en-US"/>
           </a:p>
@@ -1830,7 +1830,7 @@
           <a:p>
             <a:fld id="{4FBA4FEC-236F-4868-8F03-87BECBE3AFDA}" type="datetimeFigureOut">
               <a:rPr lang="en-US" smtClean="0"/>
-              <a:t>7/26/2025</a:t>
+              <a:t>8/5/2025</a:t>
             </a:fld>
             <a:endParaRPr lang="en-US"/>
           </a:p>
@@ -2107,7 +2107,7 @@
           <a:p>
             <a:fld id="{4FBA4FEC-236F-4868-8F03-87BECBE3AFDA}" type="datetimeFigureOut">
               <a:rPr lang="en-US" smtClean="0"/>
-              <a:t>7/26/2025</a:t>
+              <a:t>8/5/2025</a:t>
             </a:fld>
             <a:endParaRPr lang="en-US"/>
           </a:p>
@@ -2364,7 +2364,7 @@
           <a:p>
             <a:fld id="{4FBA4FEC-236F-4868-8F03-87BECBE3AFDA}" type="datetimeFigureOut">
               <a:rPr lang="en-US" smtClean="0"/>
-              <a:t>7/26/2025</a:t>
+              <a:t>8/5/2025</a:t>
             </a:fld>
             <a:endParaRPr lang="en-US"/>
           </a:p>
@@ -2577,7 +2577,7 @@
           <a:p>
             <a:fld id="{4FBA4FEC-236F-4868-8F03-87BECBE3AFDA}" type="datetimeFigureOut">
               <a:rPr lang="en-US" smtClean="0"/>
-              <a:t>7/26/2025</a:t>
+              <a:t>8/5/2025</a:t>
             </a:fld>
             <a:endParaRPr lang="en-US"/>
           </a:p>

</xml_diff>

<commit_message>
Add PopUpProductListController and update assets
Added new PopUpProductListController.java for product list popup functionality. Added two database backup SQL files. Renamed and updated several document and presentation files. Modified CashierInvoiceController and Product_registrationController for related changes.
</commit_message>
<xml_diff>
--- a/Assets/Docs/payment Receipt.pptx
+++ b/Assets/Docs/payment Receipt.pptx
@@ -254,7 +254,7 @@
           <a:p>
             <a:fld id="{4FBA4FEC-236F-4868-8F03-87BECBE3AFDA}" type="datetimeFigureOut">
               <a:rPr lang="en-US" smtClean="0"/>
-              <a:t>8/5/2025</a:t>
+              <a:t>8/9/2025</a:t>
             </a:fld>
             <a:endParaRPr lang="en-US"/>
           </a:p>
@@ -424,7 +424,7 @@
           <a:p>
             <a:fld id="{4FBA4FEC-236F-4868-8F03-87BECBE3AFDA}" type="datetimeFigureOut">
               <a:rPr lang="en-US" smtClean="0"/>
-              <a:t>8/5/2025</a:t>
+              <a:t>8/9/2025</a:t>
             </a:fld>
             <a:endParaRPr lang="en-US"/>
           </a:p>
@@ -604,7 +604,7 @@
           <a:p>
             <a:fld id="{4FBA4FEC-236F-4868-8F03-87BECBE3AFDA}" type="datetimeFigureOut">
               <a:rPr lang="en-US" smtClean="0"/>
-              <a:t>8/5/2025</a:t>
+              <a:t>8/9/2025</a:t>
             </a:fld>
             <a:endParaRPr lang="en-US"/>
           </a:p>
@@ -774,7 +774,7 @@
           <a:p>
             <a:fld id="{4FBA4FEC-236F-4868-8F03-87BECBE3AFDA}" type="datetimeFigureOut">
               <a:rPr lang="en-US" smtClean="0"/>
-              <a:t>8/5/2025</a:t>
+              <a:t>8/9/2025</a:t>
             </a:fld>
             <a:endParaRPr lang="en-US"/>
           </a:p>
@@ -1018,7 +1018,7 @@
           <a:p>
             <a:fld id="{4FBA4FEC-236F-4868-8F03-87BECBE3AFDA}" type="datetimeFigureOut">
               <a:rPr lang="en-US" smtClean="0"/>
-              <a:t>8/5/2025</a:t>
+              <a:t>8/9/2025</a:t>
             </a:fld>
             <a:endParaRPr lang="en-US"/>
           </a:p>
@@ -1250,7 +1250,7 @@
           <a:p>
             <a:fld id="{4FBA4FEC-236F-4868-8F03-87BECBE3AFDA}" type="datetimeFigureOut">
               <a:rPr lang="en-US" smtClean="0"/>
-              <a:t>8/5/2025</a:t>
+              <a:t>8/9/2025</a:t>
             </a:fld>
             <a:endParaRPr lang="en-US"/>
           </a:p>
@@ -1617,7 +1617,7 @@
           <a:p>
             <a:fld id="{4FBA4FEC-236F-4868-8F03-87BECBE3AFDA}" type="datetimeFigureOut">
               <a:rPr lang="en-US" smtClean="0"/>
-              <a:t>8/5/2025</a:t>
+              <a:t>8/9/2025</a:t>
             </a:fld>
             <a:endParaRPr lang="en-US"/>
           </a:p>
@@ -1735,7 +1735,7 @@
           <a:p>
             <a:fld id="{4FBA4FEC-236F-4868-8F03-87BECBE3AFDA}" type="datetimeFigureOut">
               <a:rPr lang="en-US" smtClean="0"/>
-              <a:t>8/5/2025</a:t>
+              <a:t>8/9/2025</a:t>
             </a:fld>
             <a:endParaRPr lang="en-US"/>
           </a:p>
@@ -1830,7 +1830,7 @@
           <a:p>
             <a:fld id="{4FBA4FEC-236F-4868-8F03-87BECBE3AFDA}" type="datetimeFigureOut">
               <a:rPr lang="en-US" smtClean="0"/>
-              <a:t>8/5/2025</a:t>
+              <a:t>8/9/2025</a:t>
             </a:fld>
             <a:endParaRPr lang="en-US"/>
           </a:p>
@@ -2107,7 +2107,7 @@
           <a:p>
             <a:fld id="{4FBA4FEC-236F-4868-8F03-87BECBE3AFDA}" type="datetimeFigureOut">
               <a:rPr lang="en-US" smtClean="0"/>
-              <a:t>8/5/2025</a:t>
+              <a:t>8/9/2025</a:t>
             </a:fld>
             <a:endParaRPr lang="en-US"/>
           </a:p>
@@ -2364,7 +2364,7 @@
           <a:p>
             <a:fld id="{4FBA4FEC-236F-4868-8F03-87BECBE3AFDA}" type="datetimeFigureOut">
               <a:rPr lang="en-US" smtClean="0"/>
-              <a:t>8/5/2025</a:t>
+              <a:t>8/9/2025</a:t>
             </a:fld>
             <a:endParaRPr lang="en-US"/>
           </a:p>
@@ -2577,7 +2577,7 @@
           <a:p>
             <a:fld id="{4FBA4FEC-236F-4868-8F03-87BECBE3AFDA}" type="datetimeFigureOut">
               <a:rPr lang="en-US" smtClean="0"/>
-              <a:t>8/5/2025</a:t>
+              <a:t>8/9/2025</a:t>
             </a:fld>
             <a:endParaRPr lang="en-US"/>
           </a:p>
@@ -4459,7 +4459,7 @@
         </p:nvSpPr>
         <p:spPr>
           <a:xfrm>
-            <a:off x="5861712" y="4863402"/>
+            <a:off x="5861712" y="5238620"/>
             <a:ext cx="716071" cy="246221"/>
           </a:xfrm>
           <a:prstGeom prst="rect">
@@ -4607,7 +4607,7 @@
         </p:nvSpPr>
         <p:spPr>
           <a:xfrm>
-            <a:off x="4129549" y="4863402"/>
+            <a:off x="4129549" y="5238620"/>
             <a:ext cx="1282724" cy="246221"/>
           </a:xfrm>
           <a:prstGeom prst="rect">
@@ -4658,7 +4658,7 @@
         </p:nvCxnSpPr>
         <p:spPr>
           <a:xfrm>
-            <a:off x="4129549" y="5114172"/>
+            <a:off x="4129549" y="5489390"/>
             <a:ext cx="2443213" cy="0"/>
           </a:xfrm>
           <a:prstGeom prst="line">
@@ -4702,7 +4702,7 @@
         </p:nvSpPr>
         <p:spPr>
           <a:xfrm>
-            <a:off x="5505000" y="5160165"/>
+            <a:off x="5505000" y="5535383"/>
             <a:ext cx="1072783" cy="246221"/>
           </a:xfrm>
           <a:prstGeom prst="rect">
@@ -4727,7 +4727,7 @@
                 </a:solidFill>
                 <a:latin typeface="Aptos" panose="020B0004020202020204" pitchFamily="34" charset="0"/>
               </a:rPr>
-              <a:t>LKR: 34,000.00</a:t>
+              <a:t>LKR: 17,500.00</a:t>
             </a:r>
             <a:endParaRPr lang="en-US" sz="1000" b="1" dirty="0">
               <a:solidFill>
@@ -4752,7 +4752,7 @@
         </p:nvSpPr>
         <p:spPr>
           <a:xfrm>
-            <a:off x="4129549" y="5160165"/>
+            <a:off x="4129549" y="5535383"/>
             <a:ext cx="1282724" cy="246221"/>
           </a:xfrm>
           <a:prstGeom prst="rect">
@@ -4803,7 +4803,7 @@
         </p:nvCxnSpPr>
         <p:spPr>
           <a:xfrm>
-            <a:off x="4129549" y="5404858"/>
+            <a:off x="4129549" y="5780076"/>
             <a:ext cx="2443213" cy="0"/>
           </a:xfrm>
           <a:prstGeom prst="line">
@@ -4849,7 +4849,7 @@
         </p:nvCxnSpPr>
         <p:spPr>
           <a:xfrm>
-            <a:off x="4129549" y="5429880"/>
+            <a:off x="4129549" y="5805098"/>
             <a:ext cx="2443213" cy="0"/>
           </a:xfrm>
           <a:prstGeom prst="line">
@@ -5627,6 +5627,105 @@
           </a:prstGeom>
         </p:spPr>
       </p:pic>
+      <p:sp>
+        <p:nvSpPr>
+          <p:cNvPr id="3" name="TextBox 2">
+            <a:extLst>
+              <a:ext uri="{FF2B5EF4-FFF2-40B4-BE49-F238E27FC236}">
+                <a16:creationId xmlns:a16="http://schemas.microsoft.com/office/drawing/2014/main" id="{AE55EBBC-FD4B-2208-DBF2-4206B5E168D5}"/>
+              </a:ext>
+            </a:extLst>
+          </p:cNvPr>
+          <p:cNvSpPr txBox="1"/>
+          <p:nvPr/>
+        </p:nvSpPr>
+        <p:spPr>
+          <a:xfrm>
+            <a:off x="5336502" y="4872692"/>
+            <a:ext cx="1241282" cy="246221"/>
+          </a:xfrm>
+          <a:prstGeom prst="rect">
+            <a:avLst/>
+          </a:prstGeom>
+          <a:noFill/>
+        </p:spPr>
+        <p:txBody>
+          <a:bodyPr wrap="square" rtlCol="0">
+            <a:spAutoFit/>
+          </a:bodyPr>
+          <a:lstStyle/>
+          <a:p>
+            <a:pPr algn="r"/>
+            <a:r>
+              <a:rPr lang="en-US" sz="1000" dirty="0">
+                <a:solidFill>
+                  <a:schemeClr val="tx1">
+                    <a:lumMod val="85000"/>
+                    <a:lumOff val="15000"/>
+                  </a:schemeClr>
+                </a:solidFill>
+                <a:latin typeface="Aptos" panose="020B0004020202020204" pitchFamily="34" charset="0"/>
+              </a:rPr>
+              <a:t>LKR: 16,500.00</a:t>
+            </a:r>
+            <a:endParaRPr lang="en-US" sz="1000" dirty="0">
+              <a:solidFill>
+                <a:srgbClr val="FF0000"/>
+              </a:solidFill>
+              <a:latin typeface="Aptos" panose="020B0004020202020204" pitchFamily="34" charset="0"/>
+            </a:endParaRPr>
+          </a:p>
+        </p:txBody>
+      </p:sp>
+      <p:sp>
+        <p:nvSpPr>
+          <p:cNvPr id="7" name="TextBox 6">
+            <a:extLst>
+              <a:ext uri="{FF2B5EF4-FFF2-40B4-BE49-F238E27FC236}">
+                <a16:creationId xmlns:a16="http://schemas.microsoft.com/office/drawing/2014/main" id="{A8D4A9DF-85F2-E240-1191-DF7D90B4007D}"/>
+              </a:ext>
+            </a:extLst>
+          </p:cNvPr>
+          <p:cNvSpPr txBox="1"/>
+          <p:nvPr/>
+        </p:nvSpPr>
+        <p:spPr>
+          <a:xfrm>
+            <a:off x="4129549" y="4878195"/>
+            <a:ext cx="1282724" cy="246221"/>
+          </a:xfrm>
+          <a:prstGeom prst="rect">
+            <a:avLst/>
+          </a:prstGeom>
+          <a:noFill/>
+        </p:spPr>
+        <p:txBody>
+          <a:bodyPr wrap="square" rtlCol="0">
+            <a:spAutoFit/>
+          </a:bodyPr>
+          <a:lstStyle/>
+          <a:p>
+            <a:r>
+              <a:rPr lang="en-US" sz="1000" dirty="0">
+                <a:solidFill>
+                  <a:schemeClr val="tx1">
+                    <a:lumMod val="85000"/>
+                    <a:lumOff val="15000"/>
+                  </a:schemeClr>
+                </a:solidFill>
+                <a:latin typeface="Aptos" panose="020B0004020202020204" pitchFamily="34" charset="0"/>
+              </a:rPr>
+              <a:t>Partial Payment</a:t>
+            </a:r>
+            <a:endParaRPr lang="en-US" sz="1000" dirty="0">
+              <a:solidFill>
+                <a:srgbClr val="FF0000"/>
+              </a:solidFill>
+              <a:latin typeface="Aptos" panose="020B0004020202020204" pitchFamily="34" charset="0"/>
+            </a:endParaRPr>
+          </a:p>
+        </p:txBody>
+      </p:sp>
     </p:spTree>
     <p:extLst>
       <p:ext uri="{BB962C8B-B14F-4D97-AF65-F5344CB8AC3E}">

</xml_diff>